<commit_message>
fix 3 IDOR playbook bugs found during PortSwigger lab testing
conflicting_identifiers: was emitting ?id=wiener (just the authorized
id) even when the identifier was query-only and there was no path or
body identifier to cross-conflict with. Now returns 0 variants unless
the context has a path OR body identifier to conflict against the query.

parameter_pollution: was emitting id=target&id=target (same value twice)
as the first variant. Same-value duplication doesn't test parameter-
precedence bugs. Removed — only the mixed authorized+target orderings
(id=auth&id=target, id=target&id=auth) remain.

identifier_aliases: first variant was id=carlos, identical to the
baseline request. Now skips parameter names that already exist in the
target request (they duplicate the baseline) and only emits real alias
names (userId, accountId, profileId, etc.).

Co-Authored-By: Claude Opus 4.6 (1M context) <noreply@anthropic.com>
</commit_message>
<xml_diff>
--- a/docs/BypassFuzzer-Presentation.pptx
+++ b/docs/BypassFuzzer-Presentation.pptx
@@ -14,6 +14,7 @@
     <p:sldId id="262" r:id="rId13"/>
     <p:sldId id="263" r:id="rId14"/>
     <p:sldId id="264" r:id="rId15"/>
+    <p:sldId id="265" r:id="rId16"/>
   </p:sldIdLst>
   <p:sldSz cx="12191695" cy="6858000" type="screen4x3"/>
   <p:notesSz cx="6858000" cy="9144000"/>
@@ -3367,6 +3368,1075 @@
 </p:sld>
 </file>
 
+<file path=ppt/slides/slide10.xml><?xml version="1.0" encoding="utf-8"?>
+<p:sld xmlns:a="http://schemas.openxmlformats.org/drawingml/2006/main" xmlns:p="http://schemas.openxmlformats.org/presentationml/2006/main" xmlns:r="http://schemas.openxmlformats.org/officeDocument/2006/relationships">
+  <p:cSld>
+    <p:spTree>
+      <p:nvGrpSpPr>
+        <p:cNvPr id="1" name=""/>
+        <p:cNvGrpSpPr/>
+        <p:nvPr/>
+      </p:nvGrpSpPr>
+      <p:grpSpPr/>
+      <p:sp>
+        <p:nvSpPr>
+          <p:cNvPr id="2" name="Rectangle 1"/>
+          <p:cNvSpPr/>
+          <p:nvPr/>
+        </p:nvSpPr>
+        <p:spPr>
+          <a:xfrm>
+            <a:off x="0" y="0"/>
+            <a:ext cx="12191695" cy="6858000"/>
+          </a:xfrm>
+          <a:prstGeom prst="rect">
+            <a:avLst/>
+          </a:prstGeom>
+          <a:solidFill>
+            <a:srgbClr val="101218"/>
+          </a:solidFill>
+          <a:ln>
+            <a:noFill/>
+          </a:ln>
+          <a:effectLst/>
+        </p:spPr>
+        <p:style>
+          <a:lnRef idx="1">
+            <a:schemeClr val="accent1"/>
+          </a:lnRef>
+          <a:fillRef idx="3">
+            <a:schemeClr val="accent1"/>
+          </a:fillRef>
+          <a:effectRef idx="2">
+            <a:schemeClr val="accent1"/>
+          </a:effectRef>
+          <a:fontRef idx="minor">
+            <a:schemeClr val="lt1"/>
+          </a:fontRef>
+        </p:style>
+        <p:txBody>
+          <a:bodyPr rtlCol="0" anchor="ctr"/>
+          <a:lstStyle/>
+          <a:p>
+            <a:pPr algn="ctr"/>
+          </a:p>
+        </p:txBody>
+      </p:sp>
+      <p:sp>
+        <p:nvSpPr>
+          <p:cNvPr id="3" name="TextBox 2"/>
+          <p:cNvSpPr txBox="1"/>
+          <p:nvPr/>
+        </p:nvSpPr>
+        <p:spPr>
+          <a:xfrm>
+            <a:off x="685800" y="502920"/>
+            <a:ext cx="10789920" cy="640080"/>
+          </a:xfrm>
+          <a:prstGeom prst="rect">
+            <a:avLst/>
+          </a:prstGeom>
+          <a:noFill/>
+        </p:spPr>
+        <p:txBody>
+          <a:bodyPr wrap="square" lIns="45720" rIns="45720" tIns="0" bIns="0">
+            <a:spAutoFit/>
+          </a:bodyPr>
+          <a:lstStyle/>
+          <a:p>
+            <a:pPr algn="l"/>
+            <a:r>
+              <a:rPr sz="3600" b="1">
+                <a:solidFill>
+                  <a:srgbClr val="E5E7EB"/>
+                </a:solidFill>
+                <a:latin typeface="Inter"/>
+              </a:rPr>
+              <a:t>IDOR / BOLA tab.</a:t>
+            </a:r>
+          </a:p>
+        </p:txBody>
+      </p:sp>
+      <p:sp>
+        <p:nvSpPr>
+          <p:cNvPr id="4" name="TextBox 3"/>
+          <p:cNvSpPr txBox="1"/>
+          <p:nvPr/>
+        </p:nvSpPr>
+        <p:spPr>
+          <a:xfrm>
+            <a:off x="685800" y="1143000"/>
+            <a:ext cx="10789920" cy="457200"/>
+          </a:xfrm>
+          <a:prstGeom prst="rect">
+            <a:avLst/>
+          </a:prstGeom>
+          <a:noFill/>
+        </p:spPr>
+        <p:txBody>
+          <a:bodyPr wrap="square" lIns="45720" rIns="45720" tIns="0" bIns="0">
+            <a:spAutoFit/>
+          </a:bodyPr>
+          <a:lstStyle/>
+          <a:p>
+            <a:pPr algn="l"/>
+            <a:r>
+              <a:rPr sz="1600" b="0">
+                <a:solidFill>
+                  <a:srgbClr val="9CA3AF"/>
+                </a:solidFill>
+                <a:latin typeface="Inter"/>
+              </a:rPr>
+              <a:t>Third bug class. Tests object-level authorization — "can I access someone else's data by changing the identifier?"</a:t>
+            </a:r>
+          </a:p>
+        </p:txBody>
+      </p:sp>
+      <p:sp>
+        <p:nvSpPr>
+          <p:cNvPr id="5" name="TextBox 4"/>
+          <p:cNvSpPr txBox="1"/>
+          <p:nvPr/>
+        </p:nvSpPr>
+        <p:spPr>
+          <a:xfrm>
+            <a:off x="685800" y="1874519"/>
+            <a:ext cx="10789920" cy="365760"/>
+          </a:xfrm>
+          <a:prstGeom prst="rect">
+            <a:avLst/>
+          </a:prstGeom>
+          <a:noFill/>
+        </p:spPr>
+        <p:txBody>
+          <a:bodyPr wrap="square" lIns="45720" rIns="45720" tIns="0" bIns="0">
+            <a:spAutoFit/>
+          </a:bodyPr>
+          <a:lstStyle/>
+          <a:p>
+            <a:pPr algn="l"/>
+            <a:r>
+              <a:rPr sz="1500" b="1">
+                <a:solidFill>
+                  <a:srgbClr val="F4A81E"/>
+                </a:solidFill>
+                <a:latin typeface="Inter"/>
+              </a:rPr>
+              <a:t>How it works</a:t>
+            </a:r>
+          </a:p>
+        </p:txBody>
+      </p:sp>
+      <p:sp>
+        <p:nvSpPr>
+          <p:cNvPr id="6" name="Rounded Rectangle 5"/>
+          <p:cNvSpPr/>
+          <p:nvPr/>
+        </p:nvSpPr>
+        <p:spPr>
+          <a:xfrm>
+            <a:off x="685800" y="2240280"/>
+            <a:ext cx="10789920" cy="1645920"/>
+          </a:xfrm>
+          <a:prstGeom prst="roundRect">
+            <a:avLst/>
+          </a:prstGeom>
+          <a:solidFill>
+            <a:srgbClr val="1B1F27"/>
+          </a:solidFill>
+          <a:ln w="9525">
+            <a:solidFill>
+              <a:srgbClr val="30353E"/>
+            </a:solidFill>
+          </a:ln>
+          <a:effectLst/>
+        </p:spPr>
+        <p:style>
+          <a:lnRef idx="1">
+            <a:schemeClr val="accent1"/>
+          </a:lnRef>
+          <a:fillRef idx="3">
+            <a:schemeClr val="accent1"/>
+          </a:fillRef>
+          <a:effectRef idx="2">
+            <a:schemeClr val="accent1"/>
+          </a:effectRef>
+          <a:fontRef idx="minor">
+            <a:schemeClr val="lt1"/>
+          </a:fontRef>
+        </p:style>
+        <p:txBody>
+          <a:bodyPr rtlCol="0" anchor="ctr"/>
+          <a:lstStyle/>
+          <a:p>
+            <a:pPr algn="ctr"/>
+          </a:p>
+        </p:txBody>
+      </p:sp>
+      <p:sp>
+        <p:nvSpPr>
+          <p:cNvPr id="7" name="TextBox 6"/>
+          <p:cNvSpPr txBox="1"/>
+          <p:nvPr/>
+        </p:nvSpPr>
+        <p:spPr>
+          <a:xfrm>
+            <a:off x="914400" y="2423160"/>
+            <a:ext cx="10332720" cy="1280160"/>
+          </a:xfrm>
+          <a:prstGeom prst="rect">
+            <a:avLst/>
+          </a:prstGeom>
+          <a:noFill/>
+        </p:spPr>
+        <p:txBody>
+          <a:bodyPr wrap="square" lIns="0" rIns="0" tIns="0" bIns="0">
+            <a:spAutoFit/>
+          </a:bodyPr>
+          <a:lstStyle/>
+          <a:p>
+            <a:pPr algn="l"/>
+            <a:r>
+              <a:rPr sz="1400">
+                <a:solidFill>
+                  <a:srgbClr val="E5E7EB"/>
+                </a:solidFill>
+                <a:latin typeface="JetBrains Mono"/>
+              </a:rPr>
+              <a:t>1. You provide two identifiers: one you own, one you don't.</a:t>
+            </a:r>
+          </a:p>
+          <a:p>
+            <a:pPr algn="l"/>
+            <a:r>
+              <a:rPr sz="1400">
+                <a:solidFill>
+                  <a:srgbClr val="E5E7EB"/>
+                </a:solidFill>
+                <a:latin typeface="JetBrains Mono"/>
+              </a:rPr>
+              <a:t>2. Tool sends YOUR id as the control — shows the "normal" response.</a:t>
+            </a:r>
+          </a:p>
+          <a:p>
+            <a:pPr algn="l"/>
+            <a:r>
+              <a:rPr sz="1400">
+                <a:solidFill>
+                  <a:srgbClr val="E5E7EB"/>
+                </a:solidFill>
+                <a:latin typeface="JetBrains Mono"/>
+              </a:rPr>
+              <a:t>3. Tool swaps in the TARGET id — whatever it returns is your baseline.</a:t>
+            </a:r>
+          </a:p>
+          <a:p>
+            <a:pPr algn="l"/>
+            <a:r>
+              <a:rPr sz="1400">
+                <a:solidFill>
+                  <a:srgbClr val="E5E7EB"/>
+                </a:solidFill>
+                <a:latin typeface="JetBrains Mono"/>
+              </a:rPr>
+              <a:t>4. Tool runs 29 playbooks mutating around the target id.</a:t>
+            </a:r>
+          </a:p>
+          <a:p>
+            <a:pPr algn="l"/>
+            <a:r>
+              <a:rPr sz="1400">
+                <a:solidFill>
+                  <a:srgbClr val="E5E7EB"/>
+                </a:solidFill>
+                <a:latin typeface="JetBrains Mono"/>
+              </a:rPr>
+              <a:t>5. You scan the results for any response that differs from baseline.</a:t>
+            </a:r>
+          </a:p>
+          <a:p>
+            <a:pPr algn="l"/>
+            <a:r>
+              <a:rPr sz="1400">
+                <a:solidFill>
+                  <a:srgbClr val="F4A81E"/>
+                </a:solidFill>
+                <a:latin typeface="JetBrains Mono"/>
+              </a:rPr>
+              <a:t>   The tool generates + fires. You are the comparator.</a:t>
+            </a:r>
+          </a:p>
+        </p:txBody>
+      </p:sp>
+      <p:sp>
+        <p:nvSpPr>
+          <p:cNvPr id="8" name="TextBox 7"/>
+          <p:cNvSpPr txBox="1"/>
+          <p:nvPr/>
+        </p:nvSpPr>
+        <p:spPr>
+          <a:xfrm>
+            <a:off x="685800" y="4069080"/>
+            <a:ext cx="10789920" cy="365760"/>
+          </a:xfrm>
+          <a:prstGeom prst="rect">
+            <a:avLst/>
+          </a:prstGeom>
+          <a:noFill/>
+        </p:spPr>
+        <p:txBody>
+          <a:bodyPr wrap="square" lIns="45720" rIns="45720" tIns="0" bIns="0">
+            <a:spAutoFit/>
+          </a:bodyPr>
+          <a:lstStyle/>
+          <a:p>
+            <a:pPr algn="l"/>
+            <a:r>
+              <a:rPr sz="1500" b="1">
+                <a:solidFill>
+                  <a:srgbClr val="F4A81E"/>
+                </a:solidFill>
+                <a:latin typeface="Inter"/>
+              </a:rPr>
+              <a:t>29 playbooks across 5 namespaces:</a:t>
+            </a:r>
+          </a:p>
+        </p:txBody>
+      </p:sp>
+      <p:sp>
+        <p:nvSpPr>
+          <p:cNvPr id="9" name="Rounded Rectangle 8"/>
+          <p:cNvSpPr/>
+          <p:nvPr/>
+        </p:nvSpPr>
+        <p:spPr>
+          <a:xfrm>
+            <a:off x="685800" y="4434840"/>
+            <a:ext cx="2103120" cy="1691640"/>
+          </a:xfrm>
+          <a:prstGeom prst="roundRect">
+            <a:avLst/>
+          </a:prstGeom>
+          <a:solidFill>
+            <a:srgbClr val="1B1F27"/>
+          </a:solidFill>
+          <a:ln w="9525">
+            <a:solidFill>
+              <a:srgbClr val="30353E"/>
+            </a:solidFill>
+          </a:ln>
+          <a:effectLst/>
+        </p:spPr>
+        <p:style>
+          <a:lnRef idx="1">
+            <a:schemeClr val="accent1"/>
+          </a:lnRef>
+          <a:fillRef idx="3">
+            <a:schemeClr val="accent1"/>
+          </a:fillRef>
+          <a:effectRef idx="2">
+            <a:schemeClr val="accent1"/>
+          </a:effectRef>
+          <a:fontRef idx="minor">
+            <a:schemeClr val="lt1"/>
+          </a:fontRef>
+        </p:style>
+        <p:txBody>
+          <a:bodyPr rtlCol="0" anchor="ctr"/>
+          <a:lstStyle/>
+          <a:p>
+            <a:pPr algn="ctr"/>
+          </a:p>
+        </p:txBody>
+      </p:sp>
+      <p:sp>
+        <p:nvSpPr>
+          <p:cNvPr id="10" name="TextBox 9"/>
+          <p:cNvSpPr txBox="1"/>
+          <p:nvPr/>
+        </p:nvSpPr>
+        <p:spPr>
+          <a:xfrm>
+            <a:off x="914400" y="4617720"/>
+            <a:ext cx="1645920" cy="1325880"/>
+          </a:xfrm>
+          <a:prstGeom prst="rect">
+            <a:avLst/>
+          </a:prstGeom>
+          <a:noFill/>
+        </p:spPr>
+        <p:txBody>
+          <a:bodyPr wrap="square" lIns="0" rIns="0" tIns="0" bIns="0">
+            <a:spAutoFit/>
+          </a:bodyPr>
+          <a:lstStyle/>
+          <a:p>
+            <a:pPr algn="l"/>
+            <a:r>
+              <a:rPr sz="1100">
+                <a:solidFill>
+                  <a:srgbClr val="F4A81E"/>
+                </a:solidFill>
+                <a:latin typeface="JetBrains Mono"/>
+              </a:rPr>
+              <a:t>idor.path.*</a:t>
+            </a:r>
+          </a:p>
+          <a:p>
+            <a:pPr algn="l"/>
+            <a:r>
+              <a:rPr sz="1100">
+                <a:solidFill>
+                  <a:srgbClr val="4ADE80"/>
+                </a:solidFill>
+                <a:latin typeface="JetBrains Mono"/>
+              </a:rPr>
+              <a:t>4 playbooks</a:t>
+            </a:r>
+          </a:p>
+          <a:p>
+            <a:pPr algn="l"/>
+            <a:r>
+              <a:rPr sz="1100">
+                <a:solidFill>
+                  <a:srgbClr val="CBE7FF"/>
+                </a:solidFill>
+                <a:latin typeface="JetBrains Mono"/>
+              </a:rPr>
+              <a:t/>
+            </a:r>
+          </a:p>
+          <a:p>
+            <a:pPr algn="l"/>
+            <a:r>
+              <a:rPr sz="1100">
+                <a:solidFill>
+                  <a:srgbClr val="9CA3AF"/>
+                </a:solidFill>
+                <a:latin typeface="JetBrains Mono"/>
+              </a:rPr>
+              <a:t>Suffix formats</a:t>
+            </a:r>
+          </a:p>
+          <a:p>
+            <a:pPr algn="l"/>
+            <a:r>
+              <a:rPr sz="1100">
+                <a:solidFill>
+                  <a:srgbClr val="9CA3AF"/>
+                </a:solidFill>
+                <a:latin typeface="JetBrains Mono"/>
+              </a:rPr>
+              <a:t>Trailing slash</a:t>
+            </a:r>
+          </a:p>
+          <a:p>
+            <a:pPr algn="l"/>
+            <a:r>
+              <a:rPr sz="1100">
+                <a:solidFill>
+                  <a:srgbClr val="9CA3AF"/>
+                </a:solidFill>
+                <a:latin typeface="JetBrains Mono"/>
+              </a:rPr>
+              <a:t>Special ID values</a:t>
+            </a:r>
+          </a:p>
+          <a:p>
+            <a:pPr algn="l"/>
+            <a:r>
+              <a:rPr sz="1100">
+                <a:solidFill>
+                  <a:srgbClr val="9CA3AF"/>
+                </a:solidFill>
+                <a:latin typeface="JetBrains Mono"/>
+              </a:rPr>
+              <a:t>Dot-segment traversal</a:t>
+            </a:r>
+          </a:p>
+        </p:txBody>
+      </p:sp>
+      <p:sp>
+        <p:nvSpPr>
+          <p:cNvPr id="11" name="Rounded Rectangle 10"/>
+          <p:cNvSpPr/>
+          <p:nvPr/>
+        </p:nvSpPr>
+        <p:spPr>
+          <a:xfrm>
+            <a:off x="2926080" y="4434840"/>
+            <a:ext cx="2103120" cy="1691640"/>
+          </a:xfrm>
+          <a:prstGeom prst="roundRect">
+            <a:avLst/>
+          </a:prstGeom>
+          <a:solidFill>
+            <a:srgbClr val="1B1F27"/>
+          </a:solidFill>
+          <a:ln w="9525">
+            <a:solidFill>
+              <a:srgbClr val="30353E"/>
+            </a:solidFill>
+          </a:ln>
+          <a:effectLst/>
+        </p:spPr>
+        <p:style>
+          <a:lnRef idx="1">
+            <a:schemeClr val="accent1"/>
+          </a:lnRef>
+          <a:fillRef idx="3">
+            <a:schemeClr val="accent1"/>
+          </a:fillRef>
+          <a:effectRef idx="2">
+            <a:schemeClr val="accent1"/>
+          </a:effectRef>
+          <a:fontRef idx="minor">
+            <a:schemeClr val="lt1"/>
+          </a:fontRef>
+        </p:style>
+        <p:txBody>
+          <a:bodyPr rtlCol="0" anchor="ctr"/>
+          <a:lstStyle/>
+          <a:p>
+            <a:pPr algn="ctr"/>
+          </a:p>
+        </p:txBody>
+      </p:sp>
+      <p:sp>
+        <p:nvSpPr>
+          <p:cNvPr id="12" name="TextBox 11"/>
+          <p:cNvSpPr txBox="1"/>
+          <p:nvPr/>
+        </p:nvSpPr>
+        <p:spPr>
+          <a:xfrm>
+            <a:off x="3154680" y="4617720"/>
+            <a:ext cx="1645920" cy="1325880"/>
+          </a:xfrm>
+          <a:prstGeom prst="rect">
+            <a:avLst/>
+          </a:prstGeom>
+          <a:noFill/>
+        </p:spPr>
+        <p:txBody>
+          <a:bodyPr wrap="square" lIns="0" rIns="0" tIns="0" bIns="0">
+            <a:spAutoFit/>
+          </a:bodyPr>
+          <a:lstStyle/>
+          <a:p>
+            <a:pPr algn="l"/>
+            <a:r>
+              <a:rPr sz="1100">
+                <a:solidFill>
+                  <a:srgbClr val="F4A81E"/>
+                </a:solidFill>
+                <a:latin typeface="JetBrains Mono"/>
+              </a:rPr>
+              <a:t>idor.query.*</a:t>
+            </a:r>
+          </a:p>
+          <a:p>
+            <a:pPr algn="l"/>
+            <a:r>
+              <a:rPr sz="1100">
+                <a:solidFill>
+                  <a:srgbClr val="4ADE80"/>
+                </a:solidFill>
+                <a:latin typeface="JetBrains Mono"/>
+              </a:rPr>
+              <a:t>5 playbooks</a:t>
+            </a:r>
+          </a:p>
+          <a:p>
+            <a:pPr algn="l"/>
+            <a:r>
+              <a:rPr sz="1100">
+                <a:solidFill>
+                  <a:srgbClr val="CBE7FF"/>
+                </a:solidFill>
+                <a:latin typeface="JetBrains Mono"/>
+              </a:rPr>
+              <a:t/>
+            </a:r>
+          </a:p>
+          <a:p>
+            <a:pPr algn="l"/>
+            <a:r>
+              <a:rPr sz="1100">
+                <a:solidFill>
+                  <a:srgbClr val="9CA3AF"/>
+                </a:solidFill>
+                <a:latin typeface="JetBrains Mono"/>
+              </a:rPr>
+              <a:t>Conflicting identifiers</a:t>
+            </a:r>
+          </a:p>
+          <a:p>
+            <a:pPr algn="l"/>
+            <a:r>
+              <a:rPr sz="1100">
+                <a:solidFill>
+                  <a:srgbClr val="9CA3AF"/>
+                </a:solidFill>
+                <a:latin typeface="JetBrains Mono"/>
+              </a:rPr>
+              <a:t>Parameter pollution</a:t>
+            </a:r>
+          </a:p>
+          <a:p>
+            <a:pPr algn="l"/>
+            <a:r>
+              <a:rPr sz="1100">
+                <a:solidFill>
+                  <a:srgbClr val="9CA3AF"/>
+                </a:solidFill>
+                <a:latin typeface="JetBrains Mono"/>
+              </a:rPr>
+              <a:t>JSON wrap / aliases</a:t>
+            </a:r>
+          </a:p>
+          <a:p>
+            <a:pPr algn="l"/>
+            <a:r>
+              <a:rPr sz="1100">
+                <a:solidFill>
+                  <a:srgbClr val="9CA3AF"/>
+                </a:solidFill>
+                <a:latin typeface="JetBrains Mono"/>
+              </a:rPr>
+              <a:t>Numeric pivots</a:t>
+            </a:r>
+          </a:p>
+        </p:txBody>
+      </p:sp>
+      <p:sp>
+        <p:nvSpPr>
+          <p:cNvPr id="13" name="Rounded Rectangle 12"/>
+          <p:cNvSpPr/>
+          <p:nvPr/>
+        </p:nvSpPr>
+        <p:spPr>
+          <a:xfrm>
+            <a:off x="5166360" y="4434840"/>
+            <a:ext cx="2103120" cy="1691640"/>
+          </a:xfrm>
+          <a:prstGeom prst="roundRect">
+            <a:avLst/>
+          </a:prstGeom>
+          <a:solidFill>
+            <a:srgbClr val="1B1F27"/>
+          </a:solidFill>
+          <a:ln w="9525">
+            <a:solidFill>
+              <a:srgbClr val="30353E"/>
+            </a:solidFill>
+          </a:ln>
+          <a:effectLst/>
+        </p:spPr>
+        <p:style>
+          <a:lnRef idx="1">
+            <a:schemeClr val="accent1"/>
+          </a:lnRef>
+          <a:fillRef idx="3">
+            <a:schemeClr val="accent1"/>
+          </a:fillRef>
+          <a:effectRef idx="2">
+            <a:schemeClr val="accent1"/>
+          </a:effectRef>
+          <a:fontRef idx="minor">
+            <a:schemeClr val="lt1"/>
+          </a:fontRef>
+        </p:style>
+        <p:txBody>
+          <a:bodyPr rtlCol="0" anchor="ctr"/>
+          <a:lstStyle/>
+          <a:p>
+            <a:pPr algn="ctr"/>
+          </a:p>
+        </p:txBody>
+      </p:sp>
+      <p:sp>
+        <p:nvSpPr>
+          <p:cNvPr id="14" name="TextBox 13"/>
+          <p:cNvSpPr txBox="1"/>
+          <p:nvPr/>
+        </p:nvSpPr>
+        <p:spPr>
+          <a:xfrm>
+            <a:off x="5394960" y="4617720"/>
+            <a:ext cx="1645920" cy="1325880"/>
+          </a:xfrm>
+          <a:prstGeom prst="rect">
+            <a:avLst/>
+          </a:prstGeom>
+          <a:noFill/>
+        </p:spPr>
+        <p:txBody>
+          <a:bodyPr wrap="square" lIns="0" rIns="0" tIns="0" bIns="0">
+            <a:spAutoFit/>
+          </a:bodyPr>
+          <a:lstStyle/>
+          <a:p>
+            <a:pPr algn="l"/>
+            <a:r>
+              <a:rPr sz="1100">
+                <a:solidFill>
+                  <a:srgbClr val="F4A81E"/>
+                </a:solidFill>
+                <a:latin typeface="JetBrains Mono"/>
+              </a:rPr>
+              <a:t>idor.body.*</a:t>
+            </a:r>
+          </a:p>
+          <a:p>
+            <a:pPr algn="l"/>
+            <a:r>
+              <a:rPr sz="1100">
+                <a:solidFill>
+                  <a:srgbClr val="4ADE80"/>
+                </a:solidFill>
+                <a:latin typeface="JetBrains Mono"/>
+              </a:rPr>
+              <a:t>6 playbooks</a:t>
+            </a:r>
+          </a:p>
+          <a:p>
+            <a:pPr algn="l"/>
+            <a:r>
+              <a:rPr sz="1100">
+                <a:solidFill>
+                  <a:srgbClr val="CBE7FF"/>
+                </a:solidFill>
+                <a:latin typeface="JetBrains Mono"/>
+              </a:rPr>
+              <a:t/>
+            </a:r>
+          </a:p>
+          <a:p>
+            <a:pPr algn="l"/>
+            <a:r>
+              <a:rPr sz="1100">
+                <a:solidFill>
+                  <a:srgbClr val="9CA3AF"/>
+                </a:solidFill>
+                <a:latin typeface="JetBrains Mono"/>
+              </a:rPr>
+              <a:t>Content-type tampering</a:t>
+            </a:r>
+          </a:p>
+          <a:p>
+            <a:pPr algn="l"/>
+            <a:r>
+              <a:rPr sz="1100">
+                <a:solidFill>
+                  <a:srgbClr val="9CA3AF"/>
+                </a:solidFill>
+                <a:latin typeface="JetBrains Mono"/>
+              </a:rPr>
+              <a:t>JSON batch / wrap / dupes</a:t>
+            </a:r>
+          </a:p>
+          <a:p>
+            <a:pPr algn="l"/>
+            <a:r>
+              <a:rPr sz="1100">
+                <a:solidFill>
+                  <a:srgbClr val="9CA3AF"/>
+                </a:solidFill>
+                <a:latin typeface="JetBrains Mono"/>
+              </a:rPr>
+              <a:t>Wildcards</a:t>
+            </a:r>
+          </a:p>
+          <a:p>
+            <a:pPr algn="l"/>
+            <a:r>
+              <a:rPr sz="1100">
+                <a:solidFill>
+                  <a:srgbClr val="9CA3AF"/>
+                </a:solidFill>
+                <a:latin typeface="JetBrains Mono"/>
+              </a:rPr>
+              <a:t>Unexpected data types</a:t>
+            </a:r>
+          </a:p>
+        </p:txBody>
+      </p:sp>
+      <p:sp>
+        <p:nvSpPr>
+          <p:cNvPr id="15" name="Rounded Rectangle 14"/>
+          <p:cNvSpPr/>
+          <p:nvPr/>
+        </p:nvSpPr>
+        <p:spPr>
+          <a:xfrm>
+            <a:off x="7406640" y="4434840"/>
+            <a:ext cx="2103120" cy="1691640"/>
+          </a:xfrm>
+          <a:prstGeom prst="roundRect">
+            <a:avLst/>
+          </a:prstGeom>
+          <a:solidFill>
+            <a:srgbClr val="1B1F27"/>
+          </a:solidFill>
+          <a:ln w="9525">
+            <a:solidFill>
+              <a:srgbClr val="30353E"/>
+            </a:solidFill>
+          </a:ln>
+          <a:effectLst/>
+        </p:spPr>
+        <p:style>
+          <a:lnRef idx="1">
+            <a:schemeClr val="accent1"/>
+          </a:lnRef>
+          <a:fillRef idx="3">
+            <a:schemeClr val="accent1"/>
+          </a:fillRef>
+          <a:effectRef idx="2">
+            <a:schemeClr val="accent1"/>
+          </a:effectRef>
+          <a:fontRef idx="minor">
+            <a:schemeClr val="lt1"/>
+          </a:fontRef>
+        </p:style>
+        <p:txBody>
+          <a:bodyPr rtlCol="0" anchor="ctr"/>
+          <a:lstStyle/>
+          <a:p>
+            <a:pPr algn="ctr"/>
+          </a:p>
+        </p:txBody>
+      </p:sp>
+      <p:sp>
+        <p:nvSpPr>
+          <p:cNvPr id="16" name="TextBox 15"/>
+          <p:cNvSpPr txBox="1"/>
+          <p:nvPr/>
+        </p:nvSpPr>
+        <p:spPr>
+          <a:xfrm>
+            <a:off x="7635240" y="4617720"/>
+            <a:ext cx="1645920" cy="1325880"/>
+          </a:xfrm>
+          <a:prstGeom prst="rect">
+            <a:avLst/>
+          </a:prstGeom>
+          <a:noFill/>
+        </p:spPr>
+        <p:txBody>
+          <a:bodyPr wrap="square" lIns="0" rIns="0" tIns="0" bIns="0">
+            <a:spAutoFit/>
+          </a:bodyPr>
+          <a:lstStyle/>
+          <a:p>
+            <a:pPr algn="l"/>
+            <a:r>
+              <a:rPr sz="1100">
+                <a:solidFill>
+                  <a:srgbClr val="F4A81E"/>
+                </a:solidFill>
+                <a:latin typeface="JetBrains Mono"/>
+              </a:rPr>
+              <a:t>idor.hybrid.*</a:t>
+            </a:r>
+          </a:p>
+          <a:p>
+            <a:pPr algn="l"/>
+            <a:r>
+              <a:rPr sz="1100">
+                <a:solidFill>
+                  <a:srgbClr val="4ADE80"/>
+                </a:solidFill>
+                <a:latin typeface="JetBrains Mono"/>
+              </a:rPr>
+              <a:t>10 playbooks</a:t>
+            </a:r>
+          </a:p>
+          <a:p>
+            <a:pPr algn="l"/>
+            <a:r>
+              <a:rPr sz="1100">
+                <a:solidFill>
+                  <a:srgbClr val="CBE7FF"/>
+                </a:solidFill>
+                <a:latin typeface="JetBrains Mono"/>
+              </a:rPr>
+              <a:t/>
+            </a:r>
+          </a:p>
+          <a:p>
+            <a:pPr algn="l"/>
+            <a:r>
+              <a:rPr sz="1100">
+                <a:solidFill>
+                  <a:srgbClr val="9CA3AF"/>
+                </a:solidFill>
+                <a:latin typeface="JetBrains Mono"/>
+              </a:rPr>
+              <a:t>Cross-source conflicts</a:t>
+            </a:r>
+          </a:p>
+          <a:p>
+            <a:pPr algn="l"/>
+            <a:r>
+              <a:rPr sz="1100">
+                <a:solidFill>
+                  <a:srgbClr val="9CA3AF"/>
+                </a:solidFill>
+                <a:latin typeface="JetBrains Mono"/>
+              </a:rPr>
+              <a:t>Case / encoding variants</a:t>
+            </a:r>
+          </a:p>
+          <a:p>
+            <a:pPr algn="l"/>
+            <a:r>
+              <a:rPr sz="1100">
+                <a:solidFill>
+                  <a:srgbClr val="9CA3AF"/>
+                </a:solidFill>
+                <a:latin typeface="JetBrains Mono"/>
+              </a:rPr>
+              <a:t>UUID neighbor edits</a:t>
+            </a:r>
+          </a:p>
+          <a:p>
+            <a:pPr algn="l"/>
+            <a:r>
+              <a:rPr sz="1100">
+                <a:solidFill>
+                  <a:srgbClr val="9CA3AF"/>
+                </a:solidFill>
+                <a:latin typeface="JetBrains Mono"/>
+              </a:rPr>
+              <a:t>Method override</a:t>
+            </a:r>
+          </a:p>
+        </p:txBody>
+      </p:sp>
+      <p:sp>
+        <p:nvSpPr>
+          <p:cNvPr id="17" name="TextBox 16"/>
+          <p:cNvSpPr txBox="1"/>
+          <p:nvPr/>
+        </p:nvSpPr>
+        <p:spPr>
+          <a:xfrm>
+            <a:off x="9646920" y="4434840"/>
+            <a:ext cx="2103120" cy="365760"/>
+          </a:xfrm>
+          <a:prstGeom prst="rect">
+            <a:avLst/>
+          </a:prstGeom>
+          <a:noFill/>
+        </p:spPr>
+        <p:txBody>
+          <a:bodyPr wrap="square" lIns="45720" rIns="45720" tIns="0" bIns="0">
+            <a:spAutoFit/>
+          </a:bodyPr>
+          <a:lstStyle/>
+          <a:p>
+            <a:pPr algn="l"/>
+            <a:r>
+              <a:rPr sz="1100" b="0">
+                <a:solidFill>
+                  <a:srgbClr val="9CA3AF"/>
+                </a:solidFill>
+                <a:latin typeface="Inter"/>
+              </a:rPr>
+              <a:t>+ 4 more in idor.header.*</a:t>
+            </a:r>
+          </a:p>
+        </p:txBody>
+      </p:sp>
+      <p:sp>
+        <p:nvSpPr>
+          <p:cNvPr id="18" name="TextBox 17"/>
+          <p:cNvSpPr txBox="1"/>
+          <p:nvPr/>
+        </p:nvSpPr>
+        <p:spPr>
+          <a:xfrm>
+            <a:off x="685800" y="6263640"/>
+            <a:ext cx="10789920" cy="320040"/>
+          </a:xfrm>
+          <a:prstGeom prst="rect">
+            <a:avLst/>
+          </a:prstGeom>
+          <a:noFill/>
+        </p:spPr>
+        <p:txBody>
+          <a:bodyPr wrap="square" lIns="45720" rIns="45720" tIns="0" bIns="0">
+            <a:spAutoFit/>
+          </a:bodyPr>
+          <a:lstStyle/>
+          <a:p>
+            <a:pPr algn="l"/>
+            <a:r>
+              <a:rPr sz="1200" b="1">
+                <a:solidFill>
+                  <a:srgbClr val="9CA3AF"/>
+                </a:solidFill>
+                <a:latin typeface="Inter"/>
+              </a:rPr>
+              <a:t>Context-aware: if the identifier lives in the path, path playbooks fire. If it's in a JSON body, body playbooks fire. Same for query string.</a:t>
+            </a:r>
+          </a:p>
+        </p:txBody>
+      </p:sp>
+      <p:sp>
+        <p:nvSpPr>
+          <p:cNvPr id="19" name="Rectangle 18"/>
+          <p:cNvSpPr/>
+          <p:nvPr/>
+        </p:nvSpPr>
+        <p:spPr>
+          <a:xfrm>
+            <a:off x="457200" y="6263640"/>
+            <a:ext cx="365760" cy="36576"/>
+          </a:xfrm>
+          <a:prstGeom prst="rect">
+            <a:avLst/>
+          </a:prstGeom>
+          <a:solidFill>
+            <a:srgbClr val="F4A81E"/>
+          </a:solidFill>
+          <a:ln>
+            <a:noFill/>
+          </a:ln>
+          <a:effectLst/>
+        </p:spPr>
+        <p:style>
+          <a:lnRef idx="1">
+            <a:schemeClr val="accent1"/>
+          </a:lnRef>
+          <a:fillRef idx="3">
+            <a:schemeClr val="accent1"/>
+          </a:fillRef>
+          <a:effectRef idx="2">
+            <a:schemeClr val="accent1"/>
+          </a:effectRef>
+          <a:fontRef idx="minor">
+            <a:schemeClr val="lt1"/>
+          </a:fontRef>
+        </p:style>
+        <p:txBody>
+          <a:bodyPr rtlCol="0" anchor="ctr"/>
+          <a:lstStyle/>
+          <a:p>
+            <a:pPr algn="ctr"/>
+          </a:p>
+        </p:txBody>
+      </p:sp>
+    </p:spTree>
+  </p:cSld>
+  <p:clrMapOvr>
+    <a:masterClrMapping/>
+  </p:clrMapOvr>
+</p:sld>
+</file>
+
 <file path=ppt/slides/slide2.xml><?xml version="1.0" encoding="utf-8"?>
 <p:sld xmlns:a="http://schemas.openxmlformats.org/drawingml/2006/main" xmlns:p="http://schemas.openxmlformats.org/presentationml/2006/main" xmlns:r="http://schemas.openxmlformats.org/officeDocument/2006/relationships">
   <p:cSld>
@@ -8062,7 +9132,7 @@
                 </a:solidFill>
                 <a:latin typeface="Inter"/>
               </a:rPr>
-              <a:t>portswigger.net/web-security/ssrf/url-validation-bypass-cheat-sheet</a:t>
+              <a:t>https://portswigger.net/web-security/ssrf/url-validation-bypass-cheat-sheet</a:t>
             </a:r>
           </a:p>
         </p:txBody>
@@ -8097,7 +9167,7 @@
                 </a:solidFill>
                 <a:latin typeface="JetBrains Mono"/>
               </a:rPr>
-              <a:t>github.com/PortSwigger/url-cheatsheet-data  ·  6 categories  ·  open to community PRs</a:t>
+              <a:t>https://github.com/PortSwigger/url-cheatsheet-data  ·  6 categories  ·  open to community PRs</a:t>
             </a:r>
           </a:p>
         </p:txBody>

</xml_diff>